<commit_message>
Initial commit all files
</commit_message>
<xml_diff>
--- a/Synthetic_Data_Generation_Agent.pptx
+++ b/Synthetic_Data_Generation_Agent.pptx
@@ -17,6 +17,7 @@
     <p:sldId id="265" r:id="rId16"/>
     <p:sldId id="266" r:id="rId17"/>
     <p:sldId id="267" r:id="rId18"/>
+    <p:sldId id="268" r:id="rId19"/>
   </p:sldIdLst>
   <p:sldSz cx="12188952" cy="6858000" type="screen4x3"/>
   <p:notesSz cx="6858000" cy="9144000"/>
@@ -5368,6 +5369,2758 @@
                 </a:solidFill>
               </a:rPr>
               <a:t>Confidential · For Client Presentation Only</a:t>
+            </a:r>
+          </a:p>
+        </p:txBody>
+      </p:sp>
+    </p:spTree>
+  </p:cSld>
+  <p:clrMapOvr>
+    <a:masterClrMapping/>
+  </p:clrMapOvr>
+</p:sld>
+</file>
+
+<file path=ppt/slides/slide13.xml><?xml version="1.0" encoding="utf-8"?>
+<p:sld xmlns:a="http://schemas.openxmlformats.org/drawingml/2006/main" xmlns:p="http://schemas.openxmlformats.org/presentationml/2006/main" xmlns:r="http://schemas.openxmlformats.org/officeDocument/2006/relationships">
+  <p:cSld>
+    <p:bg>
+      <p:bgPr>
+        <a:solidFill>
+          <a:srgbClr val="0D1117"/>
+        </a:solidFill>
+        <a:effectLst/>
+      </p:bgPr>
+    </p:bg>
+    <p:spTree>
+      <p:nvGrpSpPr>
+        <p:cNvPr id="1" name=""/>
+        <p:cNvGrpSpPr/>
+        <p:nvPr/>
+      </p:nvGrpSpPr>
+      <p:grpSpPr/>
+      <p:sp>
+        <p:nvSpPr>
+          <p:cNvPr id="2" name="Rectangle 1"/>
+          <p:cNvSpPr/>
+          <p:nvPr/>
+        </p:nvSpPr>
+        <p:spPr>
+          <a:xfrm>
+            <a:off x="0" y="0"/>
+            <a:ext cx="12188952" cy="6858000"/>
+          </a:xfrm>
+          <a:prstGeom prst="rect">
+            <a:avLst/>
+          </a:prstGeom>
+          <a:ln>
+            <a:noFill/>
+          </a:ln>
+          <a:gradFill rotWithShape="1">
+            <a:gsLst>
+              <a:gs pos="0">
+                <a:srgbClr val="0A0E1A"/>
+              </a:gs>
+              <a:gs pos="100000">
+                <a:srgbClr val="0C284A"/>
+              </a:gs>
+            </a:gsLst>
+            <a:lin ang="5400000" scaled="0"/>
+          </a:gradFill>
+        </p:spPr>
+        <p:style>
+          <a:lnRef idx="1">
+            <a:schemeClr val="accent1"/>
+          </a:lnRef>
+          <a:fillRef idx="3">
+            <a:schemeClr val="accent1"/>
+          </a:fillRef>
+          <a:effectRef idx="2">
+            <a:schemeClr val="accent1"/>
+          </a:effectRef>
+          <a:fontRef idx="minor">
+            <a:schemeClr val="lt1"/>
+          </a:fontRef>
+        </p:style>
+        <p:txBody>
+          <a:bodyPr rtlCol="0" anchor="ctr"/>
+          <a:lstStyle/>
+          <a:p>
+            <a:pPr algn="ctr"/>
+          </a:p>
+        </p:txBody>
+      </p:sp>
+      <p:sp>
+        <p:nvSpPr>
+          <p:cNvPr id="3" name="Rectangle 2"/>
+          <p:cNvSpPr/>
+          <p:nvPr/>
+        </p:nvSpPr>
+        <p:spPr>
+          <a:xfrm>
+            <a:off x="0" y="0"/>
+            <a:ext cx="12188952" cy="54864"/>
+          </a:xfrm>
+          <a:prstGeom prst="rect">
+            <a:avLst/>
+          </a:prstGeom>
+          <a:solidFill>
+            <a:srgbClr val="63B3ED"/>
+          </a:solidFill>
+          <a:ln>
+            <a:noFill/>
+          </a:ln>
+        </p:spPr>
+        <p:style>
+          <a:lnRef idx="1">
+            <a:schemeClr val="accent1"/>
+          </a:lnRef>
+          <a:fillRef idx="3">
+            <a:schemeClr val="accent1"/>
+          </a:fillRef>
+          <a:effectRef idx="2">
+            <a:schemeClr val="accent1"/>
+          </a:effectRef>
+          <a:fontRef idx="minor">
+            <a:schemeClr val="lt1"/>
+          </a:fontRef>
+        </p:style>
+        <p:txBody>
+          <a:bodyPr rtlCol="0" anchor="ctr"/>
+          <a:lstStyle/>
+          <a:p>
+            <a:pPr algn="ctr"/>
+          </a:p>
+        </p:txBody>
+      </p:sp>
+      <p:sp>
+        <p:nvSpPr>
+          <p:cNvPr id="4" name="Rectangle 3"/>
+          <p:cNvSpPr/>
+          <p:nvPr/>
+        </p:nvSpPr>
+        <p:spPr>
+          <a:xfrm>
+            <a:off x="9601200" y="0"/>
+            <a:ext cx="2587752" cy="1828800"/>
+          </a:xfrm>
+          <a:prstGeom prst="rect">
+            <a:avLst/>
+          </a:prstGeom>
+          <a:ln>
+            <a:noFill/>
+          </a:ln>
+          <a:gradFill rotWithShape="1">
+            <a:gsLst>
+              <a:gs pos="0">
+                <a:srgbClr val="1A3A6A"/>
+              </a:gs>
+              <a:gs pos="100000">
+                <a:srgbClr val="0A0E1A"/>
+              </a:gs>
+            </a:gsLst>
+            <a:lin ang="5400000" scaled="0"/>
+          </a:gradFill>
+        </p:spPr>
+        <p:style>
+          <a:lnRef idx="1">
+            <a:schemeClr val="accent1"/>
+          </a:lnRef>
+          <a:fillRef idx="3">
+            <a:schemeClr val="accent1"/>
+          </a:fillRef>
+          <a:effectRef idx="2">
+            <a:schemeClr val="accent1"/>
+          </a:effectRef>
+          <a:fontRef idx="minor">
+            <a:schemeClr val="lt1"/>
+          </a:fontRef>
+        </p:style>
+        <p:txBody>
+          <a:bodyPr rtlCol="0" anchor="ctr"/>
+          <a:lstStyle/>
+          <a:p>
+            <a:pPr algn="ctr"/>
+          </a:p>
+        </p:txBody>
+      </p:sp>
+      <p:sp>
+        <p:nvSpPr>
+          <p:cNvPr id="5" name="Rectangle 4"/>
+          <p:cNvSpPr/>
+          <p:nvPr/>
+        </p:nvSpPr>
+        <p:spPr>
+          <a:xfrm>
+            <a:off x="0" y="54864"/>
+            <a:ext cx="12188952" cy="868680"/>
+          </a:xfrm>
+          <a:prstGeom prst="rect">
+            <a:avLst/>
+          </a:prstGeom>
+          <a:solidFill>
+            <a:srgbClr val="101E38"/>
+          </a:solidFill>
+          <a:ln>
+            <a:noFill/>
+          </a:ln>
+        </p:spPr>
+        <p:style>
+          <a:lnRef idx="1">
+            <a:schemeClr val="accent1"/>
+          </a:lnRef>
+          <a:fillRef idx="3">
+            <a:schemeClr val="accent1"/>
+          </a:fillRef>
+          <a:effectRef idx="2">
+            <a:schemeClr val="accent1"/>
+          </a:effectRef>
+          <a:fontRef idx="minor">
+            <a:schemeClr val="lt1"/>
+          </a:fontRef>
+        </p:style>
+        <p:txBody>
+          <a:bodyPr rtlCol="0" anchor="ctr"/>
+          <a:lstStyle/>
+          <a:p>
+            <a:pPr algn="ctr"/>
+          </a:p>
+        </p:txBody>
+      </p:sp>
+      <p:sp>
+        <p:nvSpPr>
+          <p:cNvPr id="6" name="Rectangle 5"/>
+          <p:cNvSpPr/>
+          <p:nvPr/>
+        </p:nvSpPr>
+        <p:spPr>
+          <a:xfrm>
+            <a:off x="320040" y="137160"/>
+            <a:ext cx="594360" cy="594360"/>
+          </a:xfrm>
+          <a:prstGeom prst="rect">
+            <a:avLst/>
+          </a:prstGeom>
+          <a:solidFill>
+            <a:srgbClr val="63B3ED"/>
+          </a:solidFill>
+          <a:ln>
+            <a:noFill/>
+          </a:ln>
+        </p:spPr>
+        <p:style>
+          <a:lnRef idx="1">
+            <a:schemeClr val="accent1"/>
+          </a:lnRef>
+          <a:fillRef idx="3">
+            <a:schemeClr val="accent1"/>
+          </a:fillRef>
+          <a:effectRef idx="2">
+            <a:schemeClr val="accent1"/>
+          </a:effectRef>
+          <a:fontRef idx="minor">
+            <a:schemeClr val="lt1"/>
+          </a:fontRef>
+        </p:style>
+        <p:txBody>
+          <a:bodyPr rtlCol="0" anchor="ctr"/>
+          <a:lstStyle/>
+          <a:p>
+            <a:pPr algn="ctr"/>
+          </a:p>
+        </p:txBody>
+      </p:sp>
+      <p:sp>
+        <p:nvSpPr>
+          <p:cNvPr id="7" name="TextBox 6"/>
+          <p:cNvSpPr txBox="1"/>
+          <p:nvPr/>
+        </p:nvSpPr>
+        <p:spPr>
+          <a:xfrm>
+            <a:off x="320040" y="128016"/>
+            <a:ext cx="594360" cy="594360"/>
+          </a:xfrm>
+          <a:prstGeom prst="rect">
+            <a:avLst/>
+          </a:prstGeom>
+          <a:noFill/>
+        </p:spPr>
+        <p:txBody>
+          <a:bodyPr wrap="square">
+            <a:spAutoFit/>
+          </a:bodyPr>
+          <a:lstStyle/>
+          <a:p>
+            <a:pPr algn="ctr"/>
+            <a:r>
+              <a:rPr sz="2200" b="0" i="0">
+                <a:solidFill>
+                  <a:srgbClr val="FFFFFF"/>
+                </a:solidFill>
+              </a:rPr>
+              <a:t>🤖</a:t>
+            </a:r>
+          </a:p>
+        </p:txBody>
+      </p:sp>
+      <p:sp>
+        <p:nvSpPr>
+          <p:cNvPr id="8" name="TextBox 7"/>
+          <p:cNvSpPr txBox="1"/>
+          <p:nvPr/>
+        </p:nvSpPr>
+        <p:spPr>
+          <a:xfrm>
+            <a:off x="1005840" y="109728"/>
+            <a:ext cx="7315200" cy="502920"/>
+          </a:xfrm>
+          <a:prstGeom prst="rect">
+            <a:avLst/>
+          </a:prstGeom>
+          <a:noFill/>
+        </p:spPr>
+        <p:txBody>
+          <a:bodyPr wrap="square">
+            <a:spAutoFit/>
+          </a:bodyPr>
+          <a:lstStyle/>
+          <a:p>
+            <a:pPr algn="l"/>
+            <a:r>
+              <a:rPr sz="2400" b="1" i="0">
+                <a:solidFill>
+                  <a:srgbClr val="FFFFFF"/>
+                </a:solidFill>
+              </a:rPr>
+              <a:t>Synthetic Data Generation Agent</a:t>
+            </a:r>
+          </a:p>
+        </p:txBody>
+      </p:sp>
+      <p:sp>
+        <p:nvSpPr>
+          <p:cNvPr id="9" name="TextBox 8"/>
+          <p:cNvSpPr txBox="1"/>
+          <p:nvPr/>
+        </p:nvSpPr>
+        <p:spPr>
+          <a:xfrm>
+            <a:off x="1005840" y="548640"/>
+            <a:ext cx="7772400" cy="320040"/>
+          </a:xfrm>
+          <a:prstGeom prst="rect">
+            <a:avLst/>
+          </a:prstGeom>
+          <a:noFill/>
+        </p:spPr>
+        <p:txBody>
+          <a:bodyPr wrap="square">
+            <a:spAutoFit/>
+          </a:bodyPr>
+          <a:lstStyle/>
+          <a:p>
+            <a:pPr algn="l"/>
+            <a:r>
+              <a:rPr sz="1100" b="0" i="1">
+                <a:solidFill>
+                  <a:srgbClr val="63B3ED"/>
+                </a:solidFill>
+              </a:rPr>
+              <a:t>LLM-powered · Schema-validated · Batch-streaming · Instantly downloadable</a:t>
+            </a:r>
+          </a:p>
+        </p:txBody>
+      </p:sp>
+      <p:sp>
+        <p:nvSpPr>
+          <p:cNvPr id="10" name="Rectangle 9"/>
+          <p:cNvSpPr/>
+          <p:nvPr/>
+        </p:nvSpPr>
+        <p:spPr>
+          <a:xfrm>
+            <a:off x="10058400" y="201168"/>
+            <a:ext cx="1828800" cy="457200"/>
+          </a:xfrm>
+          <a:prstGeom prst="rect">
+            <a:avLst/>
+          </a:prstGeom>
+          <a:solidFill>
+            <a:srgbClr val="1A2644"/>
+          </a:solidFill>
+          <a:ln w="12700">
+            <a:solidFill>
+              <a:srgbClr val="63B3ED"/>
+            </a:solidFill>
+          </a:ln>
+        </p:spPr>
+        <p:style>
+          <a:lnRef idx="1">
+            <a:schemeClr val="accent1"/>
+          </a:lnRef>
+          <a:fillRef idx="3">
+            <a:schemeClr val="accent1"/>
+          </a:fillRef>
+          <a:effectRef idx="2">
+            <a:schemeClr val="accent1"/>
+          </a:effectRef>
+          <a:fontRef idx="minor">
+            <a:schemeClr val="lt1"/>
+          </a:fontRef>
+        </p:style>
+        <p:txBody>
+          <a:bodyPr rtlCol="0" anchor="ctr"/>
+          <a:lstStyle/>
+          <a:p>
+            <a:pPr algn="ctr"/>
+          </a:p>
+        </p:txBody>
+      </p:sp>
+      <p:sp>
+        <p:nvSpPr>
+          <p:cNvPr id="11" name="TextBox 10"/>
+          <p:cNvSpPr txBox="1"/>
+          <p:nvPr/>
+        </p:nvSpPr>
+        <p:spPr>
+          <a:xfrm>
+            <a:off x="10058400" y="201168"/>
+            <a:ext cx="1828800" cy="457200"/>
+          </a:xfrm>
+          <a:prstGeom prst="rect">
+            <a:avLst/>
+          </a:prstGeom>
+          <a:noFill/>
+        </p:spPr>
+        <p:txBody>
+          <a:bodyPr wrap="square">
+            <a:spAutoFit/>
+          </a:bodyPr>
+          <a:lstStyle/>
+          <a:p>
+            <a:pPr algn="ctr"/>
+            <a:r>
+              <a:rPr sz="900" b="1" i="0">
+                <a:solidFill>
+                  <a:srgbClr val="76E4F7"/>
+                </a:solidFill>
+              </a:rPr>
+              <a:t>⚡ Databricks · Claude Sonnet</a:t>
+            </a:r>
+          </a:p>
+        </p:txBody>
+      </p:sp>
+      <p:sp>
+        <p:nvSpPr>
+          <p:cNvPr id="12" name="Rectangle 11"/>
+          <p:cNvSpPr/>
+          <p:nvPr/>
+        </p:nvSpPr>
+        <p:spPr>
+          <a:xfrm>
+            <a:off x="228600" y="1005840"/>
+            <a:ext cx="4754880" cy="1600200"/>
+          </a:xfrm>
+          <a:prstGeom prst="rect">
+            <a:avLst/>
+          </a:prstGeom>
+          <a:solidFill>
+            <a:srgbClr val="16213E"/>
+          </a:solidFill>
+          <a:ln w="15240">
+            <a:solidFill>
+              <a:srgbClr val="63B3ED"/>
+            </a:solidFill>
+          </a:ln>
+        </p:spPr>
+        <p:style>
+          <a:lnRef idx="1">
+            <a:schemeClr val="accent1"/>
+          </a:lnRef>
+          <a:fillRef idx="3">
+            <a:schemeClr val="accent1"/>
+          </a:fillRef>
+          <a:effectRef idx="2">
+            <a:schemeClr val="accent1"/>
+          </a:effectRef>
+          <a:fontRef idx="minor">
+            <a:schemeClr val="lt1"/>
+          </a:fontRef>
+        </p:style>
+        <p:txBody>
+          <a:bodyPr rtlCol="0" anchor="ctr"/>
+          <a:lstStyle/>
+          <a:p>
+            <a:pPr algn="ctr"/>
+          </a:p>
+        </p:txBody>
+      </p:sp>
+      <p:sp>
+        <p:nvSpPr>
+          <p:cNvPr id="13" name="TextBox 12"/>
+          <p:cNvSpPr txBox="1"/>
+          <p:nvPr/>
+        </p:nvSpPr>
+        <p:spPr>
+          <a:xfrm>
+            <a:off x="365760" y="1051560"/>
+            <a:ext cx="4389120" cy="347472"/>
+          </a:xfrm>
+          <a:prstGeom prst="rect">
+            <a:avLst/>
+          </a:prstGeom>
+          <a:noFill/>
+        </p:spPr>
+        <p:txBody>
+          <a:bodyPr wrap="square">
+            <a:spAutoFit/>
+          </a:bodyPr>
+          <a:lstStyle/>
+          <a:p>
+            <a:pPr algn="l"/>
+            <a:r>
+              <a:rPr sz="1300" b="1" i="0">
+                <a:solidFill>
+                  <a:srgbClr val="63B3ED"/>
+                </a:solidFill>
+              </a:rPr>
+              <a:t>✨  What It Does</a:t>
+            </a:r>
+          </a:p>
+        </p:txBody>
+      </p:sp>
+      <p:sp>
+        <p:nvSpPr>
+          <p:cNvPr id="14" name="TextBox 13"/>
+          <p:cNvSpPr txBox="1"/>
+          <p:nvPr/>
+        </p:nvSpPr>
+        <p:spPr>
+          <a:xfrm>
+            <a:off x="365760" y="1426464"/>
+            <a:ext cx="4480560" cy="1097280"/>
+          </a:xfrm>
+          <a:prstGeom prst="rect">
+            <a:avLst/>
+          </a:prstGeom>
+          <a:noFill/>
+        </p:spPr>
+        <p:txBody>
+          <a:bodyPr wrap="square">
+            <a:spAutoFit/>
+          </a:bodyPr>
+          <a:lstStyle/>
+          <a:p>
+            <a:pPr algn="l"/>
+            <a:r>
+              <a:rPr sz="1050" b="0" i="0">
+                <a:solidFill>
+                  <a:srgbClr val="A8B2D8"/>
+                </a:solidFill>
+              </a:rPr>
+              <a:t>A Streamlit web app that uses Claude Sonnet via Databricks to generate realistic, rule-compliant synthetic datasets on demand. Users pick the data type, row count &amp; batch size — the agent handles prompting, parsing, validation &amp; download.</a:t>
+            </a:r>
+          </a:p>
+        </p:txBody>
+      </p:sp>
+      <p:sp>
+        <p:nvSpPr>
+          <p:cNvPr id="15" name="Rectangle 14"/>
+          <p:cNvSpPr/>
+          <p:nvPr/>
+        </p:nvSpPr>
+        <p:spPr>
+          <a:xfrm>
+            <a:off x="5166360" y="1005840"/>
+            <a:ext cx="6766560" cy="1600200"/>
+          </a:xfrm>
+          <a:prstGeom prst="rect">
+            <a:avLst/>
+          </a:prstGeom>
+          <a:solidFill>
+            <a:srgbClr val="16213E"/>
+          </a:solidFill>
+          <a:ln w="15240">
+            <a:solidFill>
+              <a:srgbClr val="68D391"/>
+            </a:solidFill>
+          </a:ln>
+        </p:spPr>
+        <p:style>
+          <a:lnRef idx="1">
+            <a:schemeClr val="accent1"/>
+          </a:lnRef>
+          <a:fillRef idx="3">
+            <a:schemeClr val="accent1"/>
+          </a:fillRef>
+          <a:effectRef idx="2">
+            <a:schemeClr val="accent1"/>
+          </a:effectRef>
+          <a:fontRef idx="minor">
+            <a:schemeClr val="lt1"/>
+          </a:fontRef>
+        </p:style>
+        <p:txBody>
+          <a:bodyPr rtlCol="0" anchor="ctr"/>
+          <a:lstStyle/>
+          <a:p>
+            <a:pPr algn="ctr"/>
+          </a:p>
+        </p:txBody>
+      </p:sp>
+      <p:sp>
+        <p:nvSpPr>
+          <p:cNvPr id="16" name="TextBox 15"/>
+          <p:cNvSpPr txBox="1"/>
+          <p:nvPr/>
+        </p:nvSpPr>
+        <p:spPr>
+          <a:xfrm>
+            <a:off x="5321808" y="1051560"/>
+            <a:ext cx="6400800" cy="347472"/>
+          </a:xfrm>
+          <a:prstGeom prst="rect">
+            <a:avLst/>
+          </a:prstGeom>
+          <a:noFill/>
+        </p:spPr>
+        <p:txBody>
+          <a:bodyPr wrap="square">
+            <a:spAutoFit/>
+          </a:bodyPr>
+          <a:lstStyle/>
+          <a:p>
+            <a:pPr algn="l"/>
+            <a:r>
+              <a:rPr sz="1300" b="1" i="0">
+                <a:solidFill>
+                  <a:srgbClr val="68D391"/>
+                </a:solidFill>
+              </a:rPr>
+              <a:t>📈  Why It's Scalable</a:t>
+            </a:r>
+          </a:p>
+        </p:txBody>
+      </p:sp>
+      <p:sp>
+        <p:nvSpPr>
+          <p:cNvPr id="17" name="TextBox 16"/>
+          <p:cNvSpPr txBox="1"/>
+          <p:nvPr/>
+        </p:nvSpPr>
+        <p:spPr>
+          <a:xfrm>
+            <a:off x="5321808" y="1444752"/>
+            <a:ext cx="6400800" cy="274320"/>
+          </a:xfrm>
+          <a:prstGeom prst="rect">
+            <a:avLst/>
+          </a:prstGeom>
+          <a:noFill/>
+        </p:spPr>
+        <p:txBody>
+          <a:bodyPr wrap="square">
+            <a:spAutoFit/>
+          </a:bodyPr>
+          <a:lstStyle/>
+          <a:p>
+            <a:pPr algn="l"/>
+            <a:r>
+              <a:rPr sz="1000" b="0" i="0">
+                <a:solidFill>
+                  <a:srgbClr val="A8B2D8"/>
+                </a:solidFill>
+              </a:rPr>
+              <a:t>🔄  Batch streaming — large volumes split into configurable batches with live progress</a:t>
+            </a:r>
+          </a:p>
+        </p:txBody>
+      </p:sp>
+      <p:sp>
+        <p:nvSpPr>
+          <p:cNvPr id="18" name="TextBox 17"/>
+          <p:cNvSpPr txBox="1"/>
+          <p:nvPr/>
+        </p:nvSpPr>
+        <p:spPr>
+          <a:xfrm>
+            <a:off x="5321808" y="1737360"/>
+            <a:ext cx="6400800" cy="274320"/>
+          </a:xfrm>
+          <a:prstGeom prst="rect">
+            <a:avLst/>
+          </a:prstGeom>
+          <a:noFill/>
+        </p:spPr>
+        <p:txBody>
+          <a:bodyPr wrap="square">
+            <a:spAutoFit/>
+          </a:bodyPr>
+          <a:lstStyle/>
+          <a:p>
+            <a:pPr algn="l"/>
+            <a:r>
+              <a:rPr sz="1000" b="0" i="0">
+                <a:solidFill>
+                  <a:srgbClr val="A8B2D8"/>
+                </a:solidFill>
+              </a:rPr>
+              <a:t>🔁  Auto-retry — 2× retries per failed batch, skips logged — never silent data loss</a:t>
+            </a:r>
+          </a:p>
+        </p:txBody>
+      </p:sp>
+      <p:sp>
+        <p:nvSpPr>
+          <p:cNvPr id="19" name="TextBox 18"/>
+          <p:cNvSpPr txBox="1"/>
+          <p:nvPr/>
+        </p:nvSpPr>
+        <p:spPr>
+          <a:xfrm>
+            <a:off x="5321808" y="2029968"/>
+            <a:ext cx="6400800" cy="274320"/>
+          </a:xfrm>
+          <a:prstGeom prst="rect">
+            <a:avLst/>
+          </a:prstGeom>
+          <a:noFill/>
+        </p:spPr>
+        <p:txBody>
+          <a:bodyPr wrap="square">
+            <a:spAutoFit/>
+          </a:bodyPr>
+          <a:lstStyle/>
+          <a:p>
+            <a:pPr algn="l"/>
+            <a:r>
+              <a:rPr sz="1000" b="0" i="0">
+                <a:solidFill>
+                  <a:srgbClr val="A8B2D8"/>
+                </a:solidFill>
+              </a:rPr>
+              <a:t>⚙️  Configurable row count, batch size &amp; prompts — zero code changes needed</a:t>
+            </a:r>
+          </a:p>
+        </p:txBody>
+      </p:sp>
+      <p:sp>
+        <p:nvSpPr>
+          <p:cNvPr id="20" name="TextBox 19"/>
+          <p:cNvSpPr txBox="1"/>
+          <p:nvPr/>
+        </p:nvSpPr>
+        <p:spPr>
+          <a:xfrm>
+            <a:off x="5321808" y="2322576"/>
+            <a:ext cx="6400800" cy="274320"/>
+          </a:xfrm>
+          <a:prstGeom prst="rect">
+            <a:avLst/>
+          </a:prstGeom>
+          <a:noFill/>
+        </p:spPr>
+        <p:txBody>
+          <a:bodyPr wrap="square">
+            <a:spAutoFit/>
+          </a:bodyPr>
+          <a:lstStyle/>
+          <a:p>
+            <a:pPr algn="l"/>
+            <a:r>
+              <a:rPr sz="1000" b="0" i="0">
+                <a:solidFill>
+                  <a:srgbClr val="A8B2D8"/>
+                </a:solidFill>
+              </a:rPr>
+              <a:t>🌐  OpenAI-compatible endpoint — swap Databricks for Azure OpenAI or any provider</a:t>
+            </a:r>
+          </a:p>
+        </p:txBody>
+      </p:sp>
+      <p:sp>
+        <p:nvSpPr>
+          <p:cNvPr id="21" name="TextBox 20"/>
+          <p:cNvSpPr txBox="1"/>
+          <p:nvPr/>
+        </p:nvSpPr>
+        <p:spPr>
+          <a:xfrm>
+            <a:off x="228600" y="2724912"/>
+            <a:ext cx="3657600" cy="256032"/>
+          </a:xfrm>
+          <a:prstGeom prst="rect">
+            <a:avLst/>
+          </a:prstGeom>
+          <a:noFill/>
+        </p:spPr>
+        <p:txBody>
+          <a:bodyPr wrap="square">
+            <a:spAutoFit/>
+          </a:bodyPr>
+          <a:lstStyle/>
+          <a:p>
+            <a:pPr algn="l"/>
+            <a:r>
+              <a:rPr sz="900" b="1" i="0">
+                <a:solidFill>
+                  <a:srgbClr val="718096"/>
+                </a:solidFill>
+              </a:rPr>
+              <a:t>SUPPORTED DATA SCHEMAS</a:t>
+            </a:r>
+          </a:p>
+        </p:txBody>
+      </p:sp>
+      <p:sp>
+        <p:nvSpPr>
+          <p:cNvPr id="22" name="Rectangle 21"/>
+          <p:cNvSpPr/>
+          <p:nvPr/>
+        </p:nvSpPr>
+        <p:spPr>
+          <a:xfrm>
+            <a:off x="228600" y="2834640"/>
+            <a:ext cx="27432" cy="2286000"/>
+          </a:xfrm>
+          <a:prstGeom prst="rect">
+            <a:avLst/>
+          </a:prstGeom>
+          <a:solidFill>
+            <a:srgbClr val="63B3ED"/>
+          </a:solidFill>
+          <a:ln>
+            <a:noFill/>
+          </a:ln>
+        </p:spPr>
+        <p:style>
+          <a:lnRef idx="1">
+            <a:schemeClr val="accent1"/>
+          </a:lnRef>
+          <a:fillRef idx="3">
+            <a:schemeClr val="accent1"/>
+          </a:fillRef>
+          <a:effectRef idx="2">
+            <a:schemeClr val="accent1"/>
+          </a:effectRef>
+          <a:fontRef idx="minor">
+            <a:schemeClr val="lt1"/>
+          </a:fontRef>
+        </p:style>
+        <p:txBody>
+          <a:bodyPr rtlCol="0" anchor="ctr"/>
+          <a:lstStyle/>
+          <a:p>
+            <a:pPr algn="ctr"/>
+          </a:p>
+        </p:txBody>
+      </p:sp>
+      <p:sp>
+        <p:nvSpPr>
+          <p:cNvPr id="23" name="Rectangle 22"/>
+          <p:cNvSpPr/>
+          <p:nvPr/>
+        </p:nvSpPr>
+        <p:spPr>
+          <a:xfrm>
+            <a:off x="320040" y="2834640"/>
+            <a:ext cx="5669280" cy="2286000"/>
+          </a:xfrm>
+          <a:prstGeom prst="rect">
+            <a:avLst/>
+          </a:prstGeom>
+          <a:solidFill>
+            <a:srgbClr val="121C35"/>
+          </a:solidFill>
+          <a:ln w="12700">
+            <a:solidFill>
+              <a:srgbClr val="63B3ED"/>
+            </a:solidFill>
+          </a:ln>
+        </p:spPr>
+        <p:style>
+          <a:lnRef idx="1">
+            <a:schemeClr val="accent1"/>
+          </a:lnRef>
+          <a:fillRef idx="3">
+            <a:schemeClr val="accent1"/>
+          </a:fillRef>
+          <a:effectRef idx="2">
+            <a:schemeClr val="accent1"/>
+          </a:effectRef>
+          <a:fontRef idx="minor">
+            <a:schemeClr val="lt1"/>
+          </a:fontRef>
+        </p:style>
+        <p:txBody>
+          <a:bodyPr rtlCol="0" anchor="ctr"/>
+          <a:lstStyle/>
+          <a:p>
+            <a:pPr algn="ctr"/>
+          </a:p>
+        </p:txBody>
+      </p:sp>
+      <p:sp>
+        <p:nvSpPr>
+          <p:cNvPr id="24" name="TextBox 23"/>
+          <p:cNvSpPr txBox="1"/>
+          <p:nvPr/>
+        </p:nvSpPr>
+        <p:spPr>
+          <a:xfrm>
+            <a:off x="475488" y="2871216"/>
+            <a:ext cx="5303520" cy="365760"/>
+          </a:xfrm>
+          <a:prstGeom prst="rect">
+            <a:avLst/>
+          </a:prstGeom>
+          <a:noFill/>
+        </p:spPr>
+        <p:txBody>
+          <a:bodyPr wrap="square">
+            <a:spAutoFit/>
+          </a:bodyPr>
+          <a:lstStyle/>
+          <a:p>
+            <a:pPr algn="l"/>
+            <a:r>
+              <a:rPr sz="1300" b="1" i="0">
+                <a:solidFill>
+                  <a:srgbClr val="63B3ED"/>
+                </a:solidFill>
+              </a:rPr>
+              <a:t>📦  Cluster  ·  CSV Output</a:t>
+            </a:r>
+          </a:p>
+        </p:txBody>
+      </p:sp>
+      <p:sp>
+        <p:nvSpPr>
+          <p:cNvPr id="25" name="TextBox 24"/>
+          <p:cNvSpPr txBox="1"/>
+          <p:nvPr/>
+        </p:nvSpPr>
+        <p:spPr>
+          <a:xfrm>
+            <a:off x="475488" y="3273552"/>
+            <a:ext cx="5303520" cy="301752"/>
+          </a:xfrm>
+          <a:prstGeom prst="rect">
+            <a:avLst/>
+          </a:prstGeom>
+          <a:noFill/>
+        </p:spPr>
+        <p:txBody>
+          <a:bodyPr wrap="square">
+            <a:spAutoFit/>
+          </a:bodyPr>
+          <a:lstStyle/>
+          <a:p>
+            <a:pPr algn="l"/>
+            <a:r>
+              <a:rPr sz="1000" b="0" i="0">
+                <a:solidFill>
+                  <a:srgbClr val="A8B2D8"/>
+                </a:solidFill>
+              </a:rPr>
+              <a:t>  ▸  STORE_NO       4-digit zero-padded  (e.g. 0142)</a:t>
+            </a:r>
+          </a:p>
+        </p:txBody>
+      </p:sp>
+      <p:sp>
+        <p:nvSpPr>
+          <p:cNvPr id="26" name="TextBox 25"/>
+          <p:cNvSpPr txBox="1"/>
+          <p:nvPr/>
+        </p:nvSpPr>
+        <p:spPr>
+          <a:xfrm>
+            <a:off x="475488" y="3593592"/>
+            <a:ext cx="5303520" cy="301752"/>
+          </a:xfrm>
+          <a:prstGeom prst="rect">
+            <a:avLst/>
+          </a:prstGeom>
+          <a:noFill/>
+        </p:spPr>
+        <p:txBody>
+          <a:bodyPr wrap="square">
+            <a:spAutoFit/>
+          </a:bodyPr>
+          <a:lstStyle/>
+          <a:p>
+            <a:pPr algn="l"/>
+            <a:r>
+              <a:rPr sz="1000" b="0" i="0">
+                <a:solidFill>
+                  <a:srgbClr val="A8B2D8"/>
+                </a:solidFill>
+              </a:rPr>
+              <a:t>  ▸  DEPT_NO        G5- + 2–4 alphanumeric  (e.g. G5-AB12)</a:t>
+            </a:r>
+          </a:p>
+        </p:txBody>
+      </p:sp>
+      <p:sp>
+        <p:nvSpPr>
+          <p:cNvPr id="27" name="TextBox 26"/>
+          <p:cNvSpPr txBox="1"/>
+          <p:nvPr/>
+        </p:nvSpPr>
+        <p:spPr>
+          <a:xfrm>
+            <a:off x="475488" y="3913632"/>
+            <a:ext cx="5303520" cy="301752"/>
+          </a:xfrm>
+          <a:prstGeom prst="rect">
+            <a:avLst/>
+          </a:prstGeom>
+          <a:noFill/>
+        </p:spPr>
+        <p:txBody>
+          <a:bodyPr wrap="square">
+            <a:spAutoFit/>
+          </a:bodyPr>
+          <a:lstStyle/>
+          <a:p>
+            <a:pPr algn="l"/>
+            <a:r>
+              <a:rPr sz="1000" b="0" i="0">
+                <a:solidFill>
+                  <a:srgbClr val="A8B2D8"/>
+                </a:solidFill>
+              </a:rPr>
+              <a:t>  ▸  CSTD_GRADE     Exactly 2 alphanumeric chars  (e.g. A1)</a:t>
+            </a:r>
+          </a:p>
+        </p:txBody>
+      </p:sp>
+      <p:sp>
+        <p:nvSpPr>
+          <p:cNvPr id="28" name="TextBox 27"/>
+          <p:cNvSpPr txBox="1"/>
+          <p:nvPr/>
+        </p:nvSpPr>
+        <p:spPr>
+          <a:xfrm>
+            <a:off x="475488" y="4233672"/>
+            <a:ext cx="5303520" cy="301752"/>
+          </a:xfrm>
+          <a:prstGeom prst="rect">
+            <a:avLst/>
+          </a:prstGeom>
+          <a:noFill/>
+        </p:spPr>
+        <p:txBody>
+          <a:bodyPr wrap="square">
+            <a:spAutoFit/>
+          </a:bodyPr>
+          <a:lstStyle/>
+          <a:p>
+            <a:pPr algn="l"/>
+            <a:r>
+              <a:rPr sz="1000" b="0" i="0">
+                <a:solidFill>
+                  <a:srgbClr val="A8B2D8"/>
+                </a:solidFill>
+              </a:rPr>
+              <a:t>  ▸  PHASE_STARTDATE  DD-MMM-YY  (e.g. 15-Jan-25)</a:t>
+            </a:r>
+          </a:p>
+        </p:txBody>
+      </p:sp>
+      <p:sp>
+        <p:nvSpPr>
+          <p:cNvPr id="29" name="TextBox 28"/>
+          <p:cNvSpPr txBox="1"/>
+          <p:nvPr/>
+        </p:nvSpPr>
+        <p:spPr>
+          <a:xfrm>
+            <a:off x="475488" y="4572000"/>
+            <a:ext cx="5303520" cy="320040"/>
+          </a:xfrm>
+          <a:prstGeom prst="rect">
+            <a:avLst/>
+          </a:prstGeom>
+          <a:noFill/>
+        </p:spPr>
+        <p:txBody>
+          <a:bodyPr wrap="square">
+            <a:spAutoFit/>
+          </a:bodyPr>
+          <a:lstStyle/>
+          <a:p>
+            <a:pPr algn="l"/>
+            <a:r>
+              <a:rPr sz="1000" b="1" i="0">
+                <a:solidFill>
+                  <a:srgbClr val="68D391"/>
+                </a:solidFill>
+              </a:rPr>
+              <a:t>✅ Unique STORE_NO + DEPT_NO guaranteed per batch</a:t>
+            </a:r>
+          </a:p>
+        </p:txBody>
+      </p:sp>
+      <p:sp>
+        <p:nvSpPr>
+          <p:cNvPr id="30" name="Rectangle 29"/>
+          <p:cNvSpPr/>
+          <p:nvPr/>
+        </p:nvSpPr>
+        <p:spPr>
+          <a:xfrm>
+            <a:off x="6199632" y="2834640"/>
+            <a:ext cx="5760720" cy="2286000"/>
+          </a:xfrm>
+          <a:prstGeom prst="rect">
+            <a:avLst/>
+          </a:prstGeom>
+          <a:solidFill>
+            <a:srgbClr val="121C35"/>
+          </a:solidFill>
+          <a:ln w="12700">
+            <a:solidFill>
+              <a:srgbClr val="76E4F7"/>
+            </a:solidFill>
+          </a:ln>
+        </p:spPr>
+        <p:style>
+          <a:lnRef idx="1">
+            <a:schemeClr val="accent1"/>
+          </a:lnRef>
+          <a:fillRef idx="3">
+            <a:schemeClr val="accent1"/>
+          </a:fillRef>
+          <a:effectRef idx="2">
+            <a:schemeClr val="accent1"/>
+          </a:effectRef>
+          <a:fontRef idx="minor">
+            <a:schemeClr val="lt1"/>
+          </a:fontRef>
+        </p:style>
+        <p:txBody>
+          <a:bodyPr rtlCol="0" anchor="ctr"/>
+          <a:lstStyle/>
+          <a:p>
+            <a:pPr algn="ctr"/>
+          </a:p>
+        </p:txBody>
+      </p:sp>
+      <p:sp>
+        <p:nvSpPr>
+          <p:cNvPr id="31" name="TextBox 30"/>
+          <p:cNvSpPr txBox="1"/>
+          <p:nvPr/>
+        </p:nvSpPr>
+        <p:spPr>
+          <a:xfrm>
+            <a:off x="6355080" y="2871216"/>
+            <a:ext cx="5394960" cy="365760"/>
+          </a:xfrm>
+          <a:prstGeom prst="rect">
+            <a:avLst/>
+          </a:prstGeom>
+          <a:noFill/>
+        </p:spPr>
+        <p:txBody>
+          <a:bodyPr wrap="square">
+            <a:spAutoFit/>
+          </a:bodyPr>
+          <a:lstStyle/>
+          <a:p>
+            <a:pPr algn="l"/>
+            <a:r>
+              <a:rPr sz="1300" b="1" i="0">
+                <a:solidFill>
+                  <a:srgbClr val="76E4F7"/>
+                </a:solidFill>
+              </a:rPr>
+              <a:t>🛍️  ProductVendor  ·  JSON Output</a:t>
+            </a:r>
+          </a:p>
+        </p:txBody>
+      </p:sp>
+      <p:sp>
+        <p:nvSpPr>
+          <p:cNvPr id="32" name="TextBox 31"/>
+          <p:cNvSpPr txBox="1"/>
+          <p:nvPr/>
+        </p:nvSpPr>
+        <p:spPr>
+          <a:xfrm>
+            <a:off x="6355080" y="3273552"/>
+            <a:ext cx="5394960" cy="301752"/>
+          </a:xfrm>
+          <a:prstGeom prst="rect">
+            <a:avLst/>
+          </a:prstGeom>
+          <a:noFill/>
+        </p:spPr>
+        <p:txBody>
+          <a:bodyPr wrap="square">
+            <a:spAutoFit/>
+          </a:bodyPr>
+          <a:lstStyle/>
+          <a:p>
+            <a:pPr algn="l"/>
+            <a:r>
+              <a:rPr sz="1000" b="0" i="0">
+                <a:solidFill>
+                  <a:srgbClr val="A8B2D8"/>
+                </a:solidFill>
+              </a:rPr>
+              <a:t>  ▸  productId         18-digit zero-padded string</a:t>
+            </a:r>
+          </a:p>
+        </p:txBody>
+      </p:sp>
+      <p:sp>
+        <p:nvSpPr>
+          <p:cNvPr id="33" name="TextBox 32"/>
+          <p:cNvSpPr txBox="1"/>
+          <p:nvPr/>
+        </p:nvSpPr>
+        <p:spPr>
+          <a:xfrm>
+            <a:off x="6355080" y="3593592"/>
+            <a:ext cx="5394960" cy="301752"/>
+          </a:xfrm>
+          <a:prstGeom prst="rect">
+            <a:avLst/>
+          </a:prstGeom>
+          <a:noFill/>
+        </p:spPr>
+        <p:txBody>
+          <a:bodyPr wrap="square">
+            <a:spAutoFit/>
+          </a:bodyPr>
+          <a:lstStyle/>
+          <a:p>
+            <a:pPr algn="l"/>
+            <a:r>
+              <a:rPr sz="1000" b="0" i="0">
+                <a:solidFill>
+                  <a:srgbClr val="A8B2D8"/>
+                </a:solidFill>
+              </a:rPr>
+              <a:t>  ▸  season.seasonYear  4-digit year  /  seasonName unique code</a:t>
+            </a:r>
+          </a:p>
+        </p:txBody>
+      </p:sp>
+      <p:sp>
+        <p:nvSpPr>
+          <p:cNvPr id="34" name="TextBox 33"/>
+          <p:cNvSpPr txBox="1"/>
+          <p:nvPr/>
+        </p:nvSpPr>
+        <p:spPr>
+          <a:xfrm>
+            <a:off x="6355080" y="3913632"/>
+            <a:ext cx="5394960" cy="301752"/>
+          </a:xfrm>
+          <a:prstGeom prst="rect">
+            <a:avLst/>
+          </a:prstGeom>
+          <a:noFill/>
+        </p:spPr>
+        <p:txBody>
+          <a:bodyPr wrap="square">
+            <a:spAutoFit/>
+          </a:bodyPr>
+          <a:lstStyle/>
+          <a:p>
+            <a:pPr algn="l"/>
+            <a:r>
+              <a:rPr sz="1000" b="0" i="0">
+                <a:solidFill>
+                  <a:srgbClr val="A8B2D8"/>
+                </a:solidFill>
+              </a:rPr>
+              <a:t>  ▸  vendors[].supplierNumber  6-char, starts with M</a:t>
+            </a:r>
+          </a:p>
+        </p:txBody>
+      </p:sp>
+      <p:sp>
+        <p:nvSpPr>
+          <p:cNvPr id="35" name="TextBox 34"/>
+          <p:cNvSpPr txBox="1"/>
+          <p:nvPr/>
+        </p:nvSpPr>
+        <p:spPr>
+          <a:xfrm>
+            <a:off x="6355080" y="4233672"/>
+            <a:ext cx="5394960" cy="301752"/>
+          </a:xfrm>
+          <a:prstGeom prst="rect">
+            <a:avLst/>
+          </a:prstGeom>
+          <a:noFill/>
+        </p:spPr>
+        <p:txBody>
+          <a:bodyPr wrap="square">
+            <a:spAutoFit/>
+          </a:bodyPr>
+          <a:lstStyle/>
+          <a:p>
+            <a:pPr algn="l"/>
+            <a:r>
+              <a:rPr sz="1000" b="0" i="0">
+                <a:solidFill>
+                  <a:srgbClr val="A8B2D8"/>
+                </a:solidFill>
+              </a:rPr>
+              <a:t>  ▸  vendors[].factoryNumber   11-digit  /  isActive true|false</a:t>
+            </a:r>
+          </a:p>
+        </p:txBody>
+      </p:sp>
+      <p:sp>
+        <p:nvSpPr>
+          <p:cNvPr id="36" name="TextBox 35"/>
+          <p:cNvSpPr txBox="1"/>
+          <p:nvPr/>
+        </p:nvSpPr>
+        <p:spPr>
+          <a:xfrm>
+            <a:off x="6355080" y="4572000"/>
+            <a:ext cx="5394960" cy="320040"/>
+          </a:xfrm>
+          <a:prstGeom prst="rect">
+            <a:avLst/>
+          </a:prstGeom>
+          <a:noFill/>
+        </p:spPr>
+        <p:txBody>
+          <a:bodyPr wrap="square">
+            <a:spAutoFit/>
+          </a:bodyPr>
+          <a:lstStyle/>
+          <a:p>
+            <a:pPr algn="l"/>
+            <a:r>
+              <a:rPr sz="1000" b="1" i="0">
+                <a:solidFill>
+                  <a:srgbClr val="68D391"/>
+                </a:solidFill>
+              </a:rPr>
+              <a:t>✅ Nested validation: season + every vendor checked on parse</a:t>
+            </a:r>
+          </a:p>
+        </p:txBody>
+      </p:sp>
+      <p:sp>
+        <p:nvSpPr>
+          <p:cNvPr id="37" name="TextBox 36"/>
+          <p:cNvSpPr txBox="1"/>
+          <p:nvPr/>
+        </p:nvSpPr>
+        <p:spPr>
+          <a:xfrm>
+            <a:off x="228600" y="5047488"/>
+            <a:ext cx="3657600" cy="256032"/>
+          </a:xfrm>
+          <a:prstGeom prst="rect">
+            <a:avLst/>
+          </a:prstGeom>
+          <a:noFill/>
+        </p:spPr>
+        <p:txBody>
+          <a:bodyPr wrap="square">
+            <a:spAutoFit/>
+          </a:bodyPr>
+          <a:lstStyle/>
+          <a:p>
+            <a:pPr algn="l"/>
+            <a:r>
+              <a:rPr sz="900" b="1" i="0">
+                <a:solidFill>
+                  <a:srgbClr val="718096"/>
+                </a:solidFill>
+              </a:rPr>
+              <a:t>ENTERPRISE USE CASES</a:t>
+            </a:r>
+          </a:p>
+        </p:txBody>
+      </p:sp>
+      <p:sp>
+        <p:nvSpPr>
+          <p:cNvPr id="38" name="Rectangle 37"/>
+          <p:cNvSpPr/>
+          <p:nvPr/>
+        </p:nvSpPr>
+        <p:spPr>
+          <a:xfrm>
+            <a:off x="228600" y="5349240"/>
+            <a:ext cx="1901952" cy="530352"/>
+          </a:xfrm>
+          <a:prstGeom prst="rect">
+            <a:avLst/>
+          </a:prstGeom>
+          <a:solidFill>
+            <a:srgbClr val="16213E"/>
+          </a:solidFill>
+          <a:ln w="12700">
+            <a:solidFill>
+              <a:srgbClr val="63B3ED"/>
+            </a:solidFill>
+          </a:ln>
+        </p:spPr>
+        <p:style>
+          <a:lnRef idx="1">
+            <a:schemeClr val="accent1"/>
+          </a:lnRef>
+          <a:fillRef idx="3">
+            <a:schemeClr val="accent1"/>
+          </a:fillRef>
+          <a:effectRef idx="2">
+            <a:schemeClr val="accent1"/>
+          </a:effectRef>
+          <a:fontRef idx="minor">
+            <a:schemeClr val="lt1"/>
+          </a:fontRef>
+        </p:style>
+        <p:txBody>
+          <a:bodyPr rtlCol="0" anchor="ctr"/>
+          <a:lstStyle/>
+          <a:p>
+            <a:pPr algn="ctr"/>
+          </a:p>
+        </p:txBody>
+      </p:sp>
+      <p:sp>
+        <p:nvSpPr>
+          <p:cNvPr id="39" name="TextBox 38"/>
+          <p:cNvSpPr txBox="1"/>
+          <p:nvPr/>
+        </p:nvSpPr>
+        <p:spPr>
+          <a:xfrm>
+            <a:off x="320040" y="5394960"/>
+            <a:ext cx="365760" cy="411480"/>
+          </a:xfrm>
+          <a:prstGeom prst="rect">
+            <a:avLst/>
+          </a:prstGeom>
+          <a:noFill/>
+        </p:spPr>
+        <p:txBody>
+          <a:bodyPr wrap="square">
+            <a:spAutoFit/>
+          </a:bodyPr>
+          <a:lstStyle/>
+          <a:p>
+            <a:pPr algn="l"/>
+            <a:r>
+              <a:rPr sz="1800" b="0" i="0">
+                <a:solidFill>
+                  <a:srgbClr val="FFFFFF"/>
+                </a:solidFill>
+              </a:rPr>
+              <a:t>🧪</a:t>
+            </a:r>
+          </a:p>
+        </p:txBody>
+      </p:sp>
+      <p:sp>
+        <p:nvSpPr>
+          <p:cNvPr id="40" name="TextBox 39"/>
+          <p:cNvSpPr txBox="1"/>
+          <p:nvPr/>
+        </p:nvSpPr>
+        <p:spPr>
+          <a:xfrm>
+            <a:off x="731520" y="5458968"/>
+            <a:ext cx="1325880" cy="347472"/>
+          </a:xfrm>
+          <a:prstGeom prst="rect">
+            <a:avLst/>
+          </a:prstGeom>
+          <a:noFill/>
+        </p:spPr>
+        <p:txBody>
+          <a:bodyPr wrap="square">
+            <a:spAutoFit/>
+          </a:bodyPr>
+          <a:lstStyle/>
+          <a:p>
+            <a:pPr algn="l"/>
+            <a:r>
+              <a:rPr sz="1000" b="1" i="0">
+                <a:solidFill>
+                  <a:srgbClr val="63B3ED"/>
+                </a:solidFill>
+              </a:rPr>
+              <a:t>QA Without PII</a:t>
+            </a:r>
+          </a:p>
+        </p:txBody>
+      </p:sp>
+      <p:sp>
+        <p:nvSpPr>
+          <p:cNvPr id="41" name="Rectangle 40"/>
+          <p:cNvSpPr/>
+          <p:nvPr/>
+        </p:nvSpPr>
+        <p:spPr>
+          <a:xfrm>
+            <a:off x="2240280" y="5349240"/>
+            <a:ext cx="1901952" cy="530352"/>
+          </a:xfrm>
+          <a:prstGeom prst="rect">
+            <a:avLst/>
+          </a:prstGeom>
+          <a:solidFill>
+            <a:srgbClr val="16213E"/>
+          </a:solidFill>
+          <a:ln w="12700">
+            <a:solidFill>
+              <a:srgbClr val="76E4F7"/>
+            </a:solidFill>
+          </a:ln>
+        </p:spPr>
+        <p:style>
+          <a:lnRef idx="1">
+            <a:schemeClr val="accent1"/>
+          </a:lnRef>
+          <a:fillRef idx="3">
+            <a:schemeClr val="accent1"/>
+          </a:fillRef>
+          <a:effectRef idx="2">
+            <a:schemeClr val="accent1"/>
+          </a:effectRef>
+          <a:fontRef idx="minor">
+            <a:schemeClr val="lt1"/>
+          </a:fontRef>
+        </p:style>
+        <p:txBody>
+          <a:bodyPr rtlCol="0" anchor="ctr"/>
+          <a:lstStyle/>
+          <a:p>
+            <a:pPr algn="ctr"/>
+          </a:p>
+        </p:txBody>
+      </p:sp>
+      <p:sp>
+        <p:nvSpPr>
+          <p:cNvPr id="42" name="TextBox 41"/>
+          <p:cNvSpPr txBox="1"/>
+          <p:nvPr/>
+        </p:nvSpPr>
+        <p:spPr>
+          <a:xfrm>
+            <a:off x="2331720" y="5394960"/>
+            <a:ext cx="365760" cy="411480"/>
+          </a:xfrm>
+          <a:prstGeom prst="rect">
+            <a:avLst/>
+          </a:prstGeom>
+          <a:noFill/>
+        </p:spPr>
+        <p:txBody>
+          <a:bodyPr wrap="square">
+            <a:spAutoFit/>
+          </a:bodyPr>
+          <a:lstStyle/>
+          <a:p>
+            <a:pPr algn="l"/>
+            <a:r>
+              <a:rPr sz="1800" b="0" i="0">
+                <a:solidFill>
+                  <a:srgbClr val="FFFFFF"/>
+                </a:solidFill>
+              </a:rPr>
+              <a:t>🏗️</a:t>
+            </a:r>
+          </a:p>
+        </p:txBody>
+      </p:sp>
+      <p:sp>
+        <p:nvSpPr>
+          <p:cNvPr id="43" name="TextBox 42"/>
+          <p:cNvSpPr txBox="1"/>
+          <p:nvPr/>
+        </p:nvSpPr>
+        <p:spPr>
+          <a:xfrm>
+            <a:off x="2743200" y="5458968"/>
+            <a:ext cx="1325880" cy="347472"/>
+          </a:xfrm>
+          <a:prstGeom prst="rect">
+            <a:avLst/>
+          </a:prstGeom>
+          <a:noFill/>
+        </p:spPr>
+        <p:txBody>
+          <a:bodyPr wrap="square">
+            <a:spAutoFit/>
+          </a:bodyPr>
+          <a:lstStyle/>
+          <a:p>
+            <a:pPr algn="l"/>
+            <a:r>
+              <a:rPr sz="1000" b="1" i="0">
+                <a:solidFill>
+                  <a:srgbClr val="76E4F7"/>
+                </a:solidFill>
+              </a:rPr>
+              <a:t>Dev Env Seeding</a:t>
+            </a:r>
+          </a:p>
+        </p:txBody>
+      </p:sp>
+      <p:sp>
+        <p:nvSpPr>
+          <p:cNvPr id="44" name="Rectangle 43"/>
+          <p:cNvSpPr/>
+          <p:nvPr/>
+        </p:nvSpPr>
+        <p:spPr>
+          <a:xfrm>
+            <a:off x="4251960" y="5349240"/>
+            <a:ext cx="1901952" cy="530352"/>
+          </a:xfrm>
+          <a:prstGeom prst="rect">
+            <a:avLst/>
+          </a:prstGeom>
+          <a:solidFill>
+            <a:srgbClr val="16213E"/>
+          </a:solidFill>
+          <a:ln w="12700">
+            <a:solidFill>
+              <a:srgbClr val="68D391"/>
+            </a:solidFill>
+          </a:ln>
+        </p:spPr>
+        <p:style>
+          <a:lnRef idx="1">
+            <a:schemeClr val="accent1"/>
+          </a:lnRef>
+          <a:fillRef idx="3">
+            <a:schemeClr val="accent1"/>
+          </a:fillRef>
+          <a:effectRef idx="2">
+            <a:schemeClr val="accent1"/>
+          </a:effectRef>
+          <a:fontRef idx="minor">
+            <a:schemeClr val="lt1"/>
+          </a:fontRef>
+        </p:style>
+        <p:txBody>
+          <a:bodyPr rtlCol="0" anchor="ctr"/>
+          <a:lstStyle/>
+          <a:p>
+            <a:pPr algn="ctr"/>
+          </a:p>
+        </p:txBody>
+      </p:sp>
+      <p:sp>
+        <p:nvSpPr>
+          <p:cNvPr id="45" name="TextBox 44"/>
+          <p:cNvSpPr txBox="1"/>
+          <p:nvPr/>
+        </p:nvSpPr>
+        <p:spPr>
+          <a:xfrm>
+            <a:off x="4343400" y="5394960"/>
+            <a:ext cx="365760" cy="411480"/>
+          </a:xfrm>
+          <a:prstGeom prst="rect">
+            <a:avLst/>
+          </a:prstGeom>
+          <a:noFill/>
+        </p:spPr>
+        <p:txBody>
+          <a:bodyPr wrap="square">
+            <a:spAutoFit/>
+          </a:bodyPr>
+          <a:lstStyle/>
+          <a:p>
+            <a:pPr algn="l"/>
+            <a:r>
+              <a:rPr sz="1800" b="0" i="0">
+                <a:solidFill>
+                  <a:srgbClr val="FFFFFF"/>
+                </a:solidFill>
+              </a:rPr>
+              <a:t>📊</a:t>
+            </a:r>
+          </a:p>
+        </p:txBody>
+      </p:sp>
+      <p:sp>
+        <p:nvSpPr>
+          <p:cNvPr id="46" name="TextBox 45"/>
+          <p:cNvSpPr txBox="1"/>
+          <p:nvPr/>
+        </p:nvSpPr>
+        <p:spPr>
+          <a:xfrm>
+            <a:off x="4754880" y="5458968"/>
+            <a:ext cx="1325880" cy="347472"/>
+          </a:xfrm>
+          <a:prstGeom prst="rect">
+            <a:avLst/>
+          </a:prstGeom>
+          <a:noFill/>
+        </p:spPr>
+        <p:txBody>
+          <a:bodyPr wrap="square">
+            <a:spAutoFit/>
+          </a:bodyPr>
+          <a:lstStyle/>
+          <a:p>
+            <a:pPr algn="l"/>
+            <a:r>
+              <a:rPr sz="1000" b="1" i="0">
+                <a:solidFill>
+                  <a:srgbClr val="68D391"/>
+                </a:solidFill>
+              </a:rPr>
+              <a:t>BI Prototyping</a:t>
+            </a:r>
+          </a:p>
+        </p:txBody>
+      </p:sp>
+      <p:sp>
+        <p:nvSpPr>
+          <p:cNvPr id="47" name="Rectangle 46"/>
+          <p:cNvSpPr/>
+          <p:nvPr/>
+        </p:nvSpPr>
+        <p:spPr>
+          <a:xfrm>
+            <a:off x="228600" y="6007607"/>
+            <a:ext cx="1901952" cy="530352"/>
+          </a:xfrm>
+          <a:prstGeom prst="rect">
+            <a:avLst/>
+          </a:prstGeom>
+          <a:solidFill>
+            <a:srgbClr val="16213E"/>
+          </a:solidFill>
+          <a:ln w="12700">
+            <a:solidFill>
+              <a:srgbClr val="B794F4"/>
+            </a:solidFill>
+          </a:ln>
+        </p:spPr>
+        <p:style>
+          <a:lnRef idx="1">
+            <a:schemeClr val="accent1"/>
+          </a:lnRef>
+          <a:fillRef idx="3">
+            <a:schemeClr val="accent1"/>
+          </a:fillRef>
+          <a:effectRef idx="2">
+            <a:schemeClr val="accent1"/>
+          </a:effectRef>
+          <a:fontRef idx="minor">
+            <a:schemeClr val="lt1"/>
+          </a:fontRef>
+        </p:style>
+        <p:txBody>
+          <a:bodyPr rtlCol="0" anchor="ctr"/>
+          <a:lstStyle/>
+          <a:p>
+            <a:pPr algn="ctr"/>
+          </a:p>
+        </p:txBody>
+      </p:sp>
+      <p:sp>
+        <p:nvSpPr>
+          <p:cNvPr id="48" name="TextBox 47"/>
+          <p:cNvSpPr txBox="1"/>
+          <p:nvPr/>
+        </p:nvSpPr>
+        <p:spPr>
+          <a:xfrm>
+            <a:off x="320040" y="6053327"/>
+            <a:ext cx="365760" cy="411480"/>
+          </a:xfrm>
+          <a:prstGeom prst="rect">
+            <a:avLst/>
+          </a:prstGeom>
+          <a:noFill/>
+        </p:spPr>
+        <p:txBody>
+          <a:bodyPr wrap="square">
+            <a:spAutoFit/>
+          </a:bodyPr>
+          <a:lstStyle/>
+          <a:p>
+            <a:pPr algn="l"/>
+            <a:r>
+              <a:rPr sz="1800" b="0" i="0">
+                <a:solidFill>
+                  <a:srgbClr val="FFFFFF"/>
+                </a:solidFill>
+              </a:rPr>
+              <a:t>🤖</a:t>
+            </a:r>
+          </a:p>
+        </p:txBody>
+      </p:sp>
+      <p:sp>
+        <p:nvSpPr>
+          <p:cNvPr id="49" name="TextBox 48"/>
+          <p:cNvSpPr txBox="1"/>
+          <p:nvPr/>
+        </p:nvSpPr>
+        <p:spPr>
+          <a:xfrm>
+            <a:off x="731520" y="6117335"/>
+            <a:ext cx="1325880" cy="347472"/>
+          </a:xfrm>
+          <a:prstGeom prst="rect">
+            <a:avLst/>
+          </a:prstGeom>
+          <a:noFill/>
+        </p:spPr>
+        <p:txBody>
+          <a:bodyPr wrap="square">
+            <a:spAutoFit/>
+          </a:bodyPr>
+          <a:lstStyle/>
+          <a:p>
+            <a:pPr algn="l"/>
+            <a:r>
+              <a:rPr sz="1000" b="1" i="0">
+                <a:solidFill>
+                  <a:srgbClr val="B794F4"/>
+                </a:solidFill>
+              </a:rPr>
+              <a:t>ML Training Data</a:t>
+            </a:r>
+          </a:p>
+        </p:txBody>
+      </p:sp>
+      <p:sp>
+        <p:nvSpPr>
+          <p:cNvPr id="50" name="Rectangle 49"/>
+          <p:cNvSpPr/>
+          <p:nvPr/>
+        </p:nvSpPr>
+        <p:spPr>
+          <a:xfrm>
+            <a:off x="2240280" y="6007607"/>
+            <a:ext cx="1901952" cy="530352"/>
+          </a:xfrm>
+          <a:prstGeom prst="rect">
+            <a:avLst/>
+          </a:prstGeom>
+          <a:solidFill>
+            <a:srgbClr val="16213E"/>
+          </a:solidFill>
+          <a:ln w="12700">
+            <a:solidFill>
+              <a:srgbClr val="F6AD55"/>
+            </a:solidFill>
+          </a:ln>
+        </p:spPr>
+        <p:style>
+          <a:lnRef idx="1">
+            <a:schemeClr val="accent1"/>
+          </a:lnRef>
+          <a:fillRef idx="3">
+            <a:schemeClr val="accent1"/>
+          </a:fillRef>
+          <a:effectRef idx="2">
+            <a:schemeClr val="accent1"/>
+          </a:effectRef>
+          <a:fontRef idx="minor">
+            <a:schemeClr val="lt1"/>
+          </a:fontRef>
+        </p:style>
+        <p:txBody>
+          <a:bodyPr rtlCol="0" anchor="ctr"/>
+          <a:lstStyle/>
+          <a:p>
+            <a:pPr algn="ctr"/>
+          </a:p>
+        </p:txBody>
+      </p:sp>
+      <p:sp>
+        <p:nvSpPr>
+          <p:cNvPr id="51" name="TextBox 50"/>
+          <p:cNvSpPr txBox="1"/>
+          <p:nvPr/>
+        </p:nvSpPr>
+        <p:spPr>
+          <a:xfrm>
+            <a:off x="2331720" y="6053327"/>
+            <a:ext cx="365760" cy="411480"/>
+          </a:xfrm>
+          <a:prstGeom prst="rect">
+            <a:avLst/>
+          </a:prstGeom>
+          <a:noFill/>
+        </p:spPr>
+        <p:txBody>
+          <a:bodyPr wrap="square">
+            <a:spAutoFit/>
+          </a:bodyPr>
+          <a:lstStyle/>
+          <a:p>
+            <a:pPr algn="l"/>
+            <a:r>
+              <a:rPr sz="1800" b="0" i="0">
+                <a:solidFill>
+                  <a:srgbClr val="FFFFFF"/>
+                </a:solidFill>
+              </a:rPr>
+              <a:t>🔐</a:t>
+            </a:r>
+          </a:p>
+        </p:txBody>
+      </p:sp>
+      <p:sp>
+        <p:nvSpPr>
+          <p:cNvPr id="52" name="TextBox 51"/>
+          <p:cNvSpPr txBox="1"/>
+          <p:nvPr/>
+        </p:nvSpPr>
+        <p:spPr>
+          <a:xfrm>
+            <a:off x="2743200" y="6117335"/>
+            <a:ext cx="1325880" cy="347472"/>
+          </a:xfrm>
+          <a:prstGeom prst="rect">
+            <a:avLst/>
+          </a:prstGeom>
+          <a:noFill/>
+        </p:spPr>
+        <p:txBody>
+          <a:bodyPr wrap="square">
+            <a:spAutoFit/>
+          </a:bodyPr>
+          <a:lstStyle/>
+          <a:p>
+            <a:pPr algn="l"/>
+            <a:r>
+              <a:rPr sz="1000" b="1" i="0">
+                <a:solidFill>
+                  <a:srgbClr val="F6AD55"/>
+                </a:solidFill>
+              </a:rPr>
+              <a:t>Privacy-Safe Sharing</a:t>
+            </a:r>
+          </a:p>
+        </p:txBody>
+      </p:sp>
+      <p:sp>
+        <p:nvSpPr>
+          <p:cNvPr id="53" name="Rectangle 52"/>
+          <p:cNvSpPr/>
+          <p:nvPr/>
+        </p:nvSpPr>
+        <p:spPr>
+          <a:xfrm>
+            <a:off x="4251960" y="6007607"/>
+            <a:ext cx="1901952" cy="530352"/>
+          </a:xfrm>
+          <a:prstGeom prst="rect">
+            <a:avLst/>
+          </a:prstGeom>
+          <a:solidFill>
+            <a:srgbClr val="16213E"/>
+          </a:solidFill>
+          <a:ln w="12700">
+            <a:solidFill>
+              <a:srgbClr val="63B3ED"/>
+            </a:solidFill>
+          </a:ln>
+        </p:spPr>
+        <p:style>
+          <a:lnRef idx="1">
+            <a:schemeClr val="accent1"/>
+          </a:lnRef>
+          <a:fillRef idx="3">
+            <a:schemeClr val="accent1"/>
+          </a:fillRef>
+          <a:effectRef idx="2">
+            <a:schemeClr val="accent1"/>
+          </a:effectRef>
+          <a:fontRef idx="minor">
+            <a:schemeClr val="lt1"/>
+          </a:fontRef>
+        </p:style>
+        <p:txBody>
+          <a:bodyPr rtlCol="0" anchor="ctr"/>
+          <a:lstStyle/>
+          <a:p>
+            <a:pPr algn="ctr"/>
+          </a:p>
+        </p:txBody>
+      </p:sp>
+      <p:sp>
+        <p:nvSpPr>
+          <p:cNvPr id="54" name="TextBox 53"/>
+          <p:cNvSpPr txBox="1"/>
+          <p:nvPr/>
+        </p:nvSpPr>
+        <p:spPr>
+          <a:xfrm>
+            <a:off x="4343400" y="6053327"/>
+            <a:ext cx="365760" cy="411480"/>
+          </a:xfrm>
+          <a:prstGeom prst="rect">
+            <a:avLst/>
+          </a:prstGeom>
+          <a:noFill/>
+        </p:spPr>
+        <p:txBody>
+          <a:bodyPr wrap="square">
+            <a:spAutoFit/>
+          </a:bodyPr>
+          <a:lstStyle/>
+          <a:p>
+            <a:pPr algn="l"/>
+            <a:r>
+              <a:rPr sz="1800" b="0" i="0">
+                <a:solidFill>
+                  <a:srgbClr val="FFFFFF"/>
+                </a:solidFill>
+              </a:rPr>
+              <a:t>📦</a:t>
+            </a:r>
+          </a:p>
+        </p:txBody>
+      </p:sp>
+      <p:sp>
+        <p:nvSpPr>
+          <p:cNvPr id="55" name="TextBox 54"/>
+          <p:cNvSpPr txBox="1"/>
+          <p:nvPr/>
+        </p:nvSpPr>
+        <p:spPr>
+          <a:xfrm>
+            <a:off x="4754880" y="6117335"/>
+            <a:ext cx="1325880" cy="347472"/>
+          </a:xfrm>
+          <a:prstGeom prst="rect">
+            <a:avLst/>
+          </a:prstGeom>
+          <a:noFill/>
+        </p:spPr>
+        <p:txBody>
+          <a:bodyPr wrap="square">
+            <a:spAutoFit/>
+          </a:bodyPr>
+          <a:lstStyle/>
+          <a:p>
+            <a:pPr algn="l"/>
+            <a:r>
+              <a:rPr sz="1000" b="1" i="0">
+                <a:solidFill>
+                  <a:srgbClr val="63B3ED"/>
+                </a:solidFill>
+              </a:rPr>
+              <a:t>Supply Chain Sim</a:t>
+            </a:r>
+          </a:p>
+        </p:txBody>
+      </p:sp>
+      <p:sp>
+        <p:nvSpPr>
+          <p:cNvPr id="56" name="TextBox 55"/>
+          <p:cNvSpPr txBox="1"/>
+          <p:nvPr/>
+        </p:nvSpPr>
+        <p:spPr>
+          <a:xfrm>
+            <a:off x="6400800" y="5047488"/>
+            <a:ext cx="4572000" cy="256032"/>
+          </a:xfrm>
+          <a:prstGeom prst="rect">
+            <a:avLst/>
+          </a:prstGeom>
+          <a:noFill/>
+        </p:spPr>
+        <p:txBody>
+          <a:bodyPr wrap="square">
+            <a:spAutoFit/>
+          </a:bodyPr>
+          <a:lstStyle/>
+          <a:p>
+            <a:pPr algn="l"/>
+            <a:r>
+              <a:rPr sz="900" b="1" i="0">
+                <a:solidFill>
+                  <a:srgbClr val="718096"/>
+                </a:solidFill>
+              </a:rPr>
+              <a:t>CORE FEATURES</a:t>
+            </a:r>
+          </a:p>
+        </p:txBody>
+      </p:sp>
+      <p:sp>
+        <p:nvSpPr>
+          <p:cNvPr id="57" name="Rectangle 56"/>
+          <p:cNvSpPr/>
+          <p:nvPr/>
+        </p:nvSpPr>
+        <p:spPr>
+          <a:xfrm>
+            <a:off x="5321808" y="5321808"/>
+            <a:ext cx="1554480" cy="1389888"/>
+          </a:xfrm>
+          <a:prstGeom prst="rect">
+            <a:avLst/>
+          </a:prstGeom>
+          <a:solidFill>
+            <a:srgbClr val="16213E"/>
+          </a:solidFill>
+          <a:ln w="12700">
+            <a:solidFill>
+              <a:srgbClr val="63B3ED"/>
+            </a:solidFill>
+          </a:ln>
+        </p:spPr>
+        <p:style>
+          <a:lnRef idx="1">
+            <a:schemeClr val="accent1"/>
+          </a:lnRef>
+          <a:fillRef idx="3">
+            <a:schemeClr val="accent1"/>
+          </a:fillRef>
+          <a:effectRef idx="2">
+            <a:schemeClr val="accent1"/>
+          </a:effectRef>
+          <a:fontRef idx="minor">
+            <a:schemeClr val="lt1"/>
+          </a:fontRef>
+        </p:style>
+        <p:txBody>
+          <a:bodyPr rtlCol="0" anchor="ctr"/>
+          <a:lstStyle/>
+          <a:p>
+            <a:pPr algn="ctr"/>
+          </a:p>
+        </p:txBody>
+      </p:sp>
+      <p:sp>
+        <p:nvSpPr>
+          <p:cNvPr id="58" name="TextBox 57"/>
+          <p:cNvSpPr txBox="1"/>
+          <p:nvPr/>
+        </p:nvSpPr>
+        <p:spPr>
+          <a:xfrm>
+            <a:off x="5870448" y="5367528"/>
+            <a:ext cx="457200" cy="411480"/>
+          </a:xfrm>
+          <a:prstGeom prst="rect">
+            <a:avLst/>
+          </a:prstGeom>
+          <a:noFill/>
+        </p:spPr>
+        <p:txBody>
+          <a:bodyPr wrap="square">
+            <a:spAutoFit/>
+          </a:bodyPr>
+          <a:lstStyle/>
+          <a:p>
+            <a:pPr algn="ctr"/>
+            <a:r>
+              <a:rPr sz="2000" b="0" i="0">
+                <a:solidFill>
+                  <a:srgbClr val="FFFFFF"/>
+                </a:solidFill>
+              </a:rPr>
+              <a:t>🧠</a:t>
+            </a:r>
+          </a:p>
+        </p:txBody>
+      </p:sp>
+      <p:sp>
+        <p:nvSpPr>
+          <p:cNvPr id="59" name="TextBox 58"/>
+          <p:cNvSpPr txBox="1"/>
+          <p:nvPr/>
+        </p:nvSpPr>
+        <p:spPr>
+          <a:xfrm>
+            <a:off x="5367528" y="5779008"/>
+            <a:ext cx="1463040" cy="274320"/>
+          </a:xfrm>
+          <a:prstGeom prst="rect">
+            <a:avLst/>
+          </a:prstGeom>
+          <a:noFill/>
+        </p:spPr>
+        <p:txBody>
+          <a:bodyPr wrap="square">
+            <a:spAutoFit/>
+          </a:bodyPr>
+          <a:lstStyle/>
+          <a:p>
+            <a:pPr algn="ctr"/>
+            <a:r>
+              <a:rPr sz="950" b="1" i="0">
+                <a:solidFill>
+                  <a:srgbClr val="63B3ED"/>
+                </a:solidFill>
+              </a:rPr>
+              <a:t>LLM-Powered</a:t>
+            </a:r>
+          </a:p>
+        </p:txBody>
+      </p:sp>
+      <p:sp>
+        <p:nvSpPr>
+          <p:cNvPr id="60" name="TextBox 59"/>
+          <p:cNvSpPr txBox="1"/>
+          <p:nvPr/>
+        </p:nvSpPr>
+        <p:spPr>
+          <a:xfrm>
+            <a:off x="5367528" y="6053328"/>
+            <a:ext cx="1463040" cy="594360"/>
+          </a:xfrm>
+          <a:prstGeom prst="rect">
+            <a:avLst/>
+          </a:prstGeom>
+          <a:noFill/>
+        </p:spPr>
+        <p:txBody>
+          <a:bodyPr wrap="square">
+            <a:spAutoFit/>
+          </a:bodyPr>
+          <a:lstStyle/>
+          <a:p>
+            <a:pPr algn="ctr"/>
+            <a:r>
+              <a:rPr sz="850" b="0" i="0">
+                <a:solidFill>
+                  <a:srgbClr val="718096"/>
+                </a:solidFill>
+              </a:rPr>
+              <a:t>Contextually rich generation via Claude Sonnet</a:t>
+            </a:r>
+          </a:p>
+        </p:txBody>
+      </p:sp>
+      <p:sp>
+        <p:nvSpPr>
+          <p:cNvPr id="61" name="Rectangle 60"/>
+          <p:cNvSpPr/>
+          <p:nvPr/>
+        </p:nvSpPr>
+        <p:spPr>
+          <a:xfrm>
+            <a:off x="7013448" y="5321808"/>
+            <a:ext cx="1554480" cy="1389888"/>
+          </a:xfrm>
+          <a:prstGeom prst="rect">
+            <a:avLst/>
+          </a:prstGeom>
+          <a:solidFill>
+            <a:srgbClr val="16213E"/>
+          </a:solidFill>
+          <a:ln w="12700">
+            <a:solidFill>
+              <a:srgbClr val="76E4F7"/>
+            </a:solidFill>
+          </a:ln>
+        </p:spPr>
+        <p:style>
+          <a:lnRef idx="1">
+            <a:schemeClr val="accent1"/>
+          </a:lnRef>
+          <a:fillRef idx="3">
+            <a:schemeClr val="accent1"/>
+          </a:fillRef>
+          <a:effectRef idx="2">
+            <a:schemeClr val="accent1"/>
+          </a:effectRef>
+          <a:fontRef idx="minor">
+            <a:schemeClr val="lt1"/>
+          </a:fontRef>
+        </p:style>
+        <p:txBody>
+          <a:bodyPr rtlCol="0" anchor="ctr"/>
+          <a:lstStyle/>
+          <a:p>
+            <a:pPr algn="ctr"/>
+          </a:p>
+        </p:txBody>
+      </p:sp>
+      <p:sp>
+        <p:nvSpPr>
+          <p:cNvPr id="62" name="TextBox 61"/>
+          <p:cNvSpPr txBox="1"/>
+          <p:nvPr/>
+        </p:nvSpPr>
+        <p:spPr>
+          <a:xfrm>
+            <a:off x="7562088" y="5367528"/>
+            <a:ext cx="457200" cy="411480"/>
+          </a:xfrm>
+          <a:prstGeom prst="rect">
+            <a:avLst/>
+          </a:prstGeom>
+          <a:noFill/>
+        </p:spPr>
+        <p:txBody>
+          <a:bodyPr wrap="square">
+            <a:spAutoFit/>
+          </a:bodyPr>
+          <a:lstStyle/>
+          <a:p>
+            <a:pPr algn="ctr"/>
+            <a:r>
+              <a:rPr sz="2000" b="0" i="0">
+                <a:solidFill>
+                  <a:srgbClr val="FFFFFF"/>
+                </a:solidFill>
+              </a:rPr>
+              <a:t>📋</a:t>
+            </a:r>
+          </a:p>
+        </p:txBody>
+      </p:sp>
+      <p:sp>
+        <p:nvSpPr>
+          <p:cNvPr id="63" name="TextBox 62"/>
+          <p:cNvSpPr txBox="1"/>
+          <p:nvPr/>
+        </p:nvSpPr>
+        <p:spPr>
+          <a:xfrm>
+            <a:off x="7059168" y="5779008"/>
+            <a:ext cx="1463040" cy="274320"/>
+          </a:xfrm>
+          <a:prstGeom prst="rect">
+            <a:avLst/>
+          </a:prstGeom>
+          <a:noFill/>
+        </p:spPr>
+        <p:txBody>
+          <a:bodyPr wrap="square">
+            <a:spAutoFit/>
+          </a:bodyPr>
+          <a:lstStyle/>
+          <a:p>
+            <a:pPr algn="ctr"/>
+            <a:r>
+              <a:rPr sz="950" b="1" i="0">
+                <a:solidFill>
+                  <a:srgbClr val="76E4F7"/>
+                </a:solidFill>
+              </a:rPr>
+              <a:t>Schema Enforced</a:t>
+            </a:r>
+          </a:p>
+        </p:txBody>
+      </p:sp>
+      <p:sp>
+        <p:nvSpPr>
+          <p:cNvPr id="64" name="TextBox 63"/>
+          <p:cNvSpPr txBox="1"/>
+          <p:nvPr/>
+        </p:nvSpPr>
+        <p:spPr>
+          <a:xfrm>
+            <a:off x="7059168" y="6053328"/>
+            <a:ext cx="1463040" cy="594360"/>
+          </a:xfrm>
+          <a:prstGeom prst="rect">
+            <a:avLst/>
+          </a:prstGeom>
+          <a:noFill/>
+        </p:spPr>
+        <p:txBody>
+          <a:bodyPr wrap="square">
+            <a:spAutoFit/>
+          </a:bodyPr>
+          <a:lstStyle/>
+          <a:p>
+            <a:pPr algn="ctr"/>
+            <a:r>
+              <a:rPr sz="850" b="0" i="0">
+                <a:solidFill>
+                  <a:srgbClr val="718096"/>
+                </a:solidFill>
+              </a:rPr>
+              <a:t>Field-level validation — wrong format = retry</a:t>
+            </a:r>
+          </a:p>
+        </p:txBody>
+      </p:sp>
+      <p:sp>
+        <p:nvSpPr>
+          <p:cNvPr id="65" name="Rectangle 64"/>
+          <p:cNvSpPr/>
+          <p:nvPr/>
+        </p:nvSpPr>
+        <p:spPr>
+          <a:xfrm>
+            <a:off x="8705088" y="5321808"/>
+            <a:ext cx="1554480" cy="1389888"/>
+          </a:xfrm>
+          <a:prstGeom prst="rect">
+            <a:avLst/>
+          </a:prstGeom>
+          <a:solidFill>
+            <a:srgbClr val="16213E"/>
+          </a:solidFill>
+          <a:ln w="12700">
+            <a:solidFill>
+              <a:srgbClr val="B794F4"/>
+            </a:solidFill>
+          </a:ln>
+        </p:spPr>
+        <p:style>
+          <a:lnRef idx="1">
+            <a:schemeClr val="accent1"/>
+          </a:lnRef>
+          <a:fillRef idx="3">
+            <a:schemeClr val="accent1"/>
+          </a:fillRef>
+          <a:effectRef idx="2">
+            <a:schemeClr val="accent1"/>
+          </a:effectRef>
+          <a:fontRef idx="minor">
+            <a:schemeClr val="lt1"/>
+          </a:fontRef>
+        </p:style>
+        <p:txBody>
+          <a:bodyPr rtlCol="0" anchor="ctr"/>
+          <a:lstStyle/>
+          <a:p>
+            <a:pPr algn="ctr"/>
+          </a:p>
+        </p:txBody>
+      </p:sp>
+      <p:sp>
+        <p:nvSpPr>
+          <p:cNvPr id="66" name="TextBox 65"/>
+          <p:cNvSpPr txBox="1"/>
+          <p:nvPr/>
+        </p:nvSpPr>
+        <p:spPr>
+          <a:xfrm>
+            <a:off x="9253728" y="5367528"/>
+            <a:ext cx="457200" cy="411480"/>
+          </a:xfrm>
+          <a:prstGeom prst="rect">
+            <a:avLst/>
+          </a:prstGeom>
+          <a:noFill/>
+        </p:spPr>
+        <p:txBody>
+          <a:bodyPr wrap="square">
+            <a:spAutoFit/>
+          </a:bodyPr>
+          <a:lstStyle/>
+          <a:p>
+            <a:pPr algn="ctr"/>
+            <a:r>
+              <a:rPr sz="2000" b="0" i="0">
+                <a:solidFill>
+                  <a:srgbClr val="FFFFFF"/>
+                </a:solidFill>
+              </a:rPr>
+              <a:t>✏️</a:t>
+            </a:r>
+          </a:p>
+        </p:txBody>
+      </p:sp>
+      <p:sp>
+        <p:nvSpPr>
+          <p:cNvPr id="67" name="TextBox 66"/>
+          <p:cNvSpPr txBox="1"/>
+          <p:nvPr/>
+        </p:nvSpPr>
+        <p:spPr>
+          <a:xfrm>
+            <a:off x="8750808" y="5779008"/>
+            <a:ext cx="1463040" cy="274320"/>
+          </a:xfrm>
+          <a:prstGeom prst="rect">
+            <a:avLst/>
+          </a:prstGeom>
+          <a:noFill/>
+        </p:spPr>
+        <p:txBody>
+          <a:bodyPr wrap="square">
+            <a:spAutoFit/>
+          </a:bodyPr>
+          <a:lstStyle/>
+          <a:p>
+            <a:pPr algn="ctr"/>
+            <a:r>
+              <a:rPr sz="950" b="1" i="0">
+                <a:solidFill>
+                  <a:srgbClr val="B794F4"/>
+                </a:solidFill>
+              </a:rPr>
+              <a:t>Editable Prompts</a:t>
+            </a:r>
+          </a:p>
+        </p:txBody>
+      </p:sp>
+      <p:sp>
+        <p:nvSpPr>
+          <p:cNvPr id="68" name="TextBox 67"/>
+          <p:cNvSpPr txBox="1"/>
+          <p:nvPr/>
+        </p:nvSpPr>
+        <p:spPr>
+          <a:xfrm>
+            <a:off x="8750808" y="6053328"/>
+            <a:ext cx="1463040" cy="594360"/>
+          </a:xfrm>
+          <a:prstGeom prst="rect">
+            <a:avLst/>
+          </a:prstGeom>
+          <a:noFill/>
+        </p:spPr>
+        <p:txBody>
+          <a:bodyPr wrap="square">
+            <a:spAutoFit/>
+          </a:bodyPr>
+          <a:lstStyle/>
+          <a:p>
+            <a:pPr algn="ctr"/>
+            <a:r>
+              <a:rPr sz="850" b="0" i="0">
+                <a:solidFill>
+                  <a:srgbClr val="718096"/>
+                </a:solidFill>
+              </a:rPr>
+              <a:t>Customise rules in the UI, no code changes</a:t>
+            </a:r>
+          </a:p>
+        </p:txBody>
+      </p:sp>
+      <p:sp>
+        <p:nvSpPr>
+          <p:cNvPr id="69" name="Rectangle 68"/>
+          <p:cNvSpPr/>
+          <p:nvPr/>
+        </p:nvSpPr>
+        <p:spPr>
+          <a:xfrm>
+            <a:off x="10396728" y="5321808"/>
+            <a:ext cx="1554480" cy="1389888"/>
+          </a:xfrm>
+          <a:prstGeom prst="rect">
+            <a:avLst/>
+          </a:prstGeom>
+          <a:solidFill>
+            <a:srgbClr val="16213E"/>
+          </a:solidFill>
+          <a:ln w="12700">
+            <a:solidFill>
+              <a:srgbClr val="F6AD55"/>
+            </a:solidFill>
+          </a:ln>
+        </p:spPr>
+        <p:style>
+          <a:lnRef idx="1">
+            <a:schemeClr val="accent1"/>
+          </a:lnRef>
+          <a:fillRef idx="3">
+            <a:schemeClr val="accent1"/>
+          </a:fillRef>
+          <a:effectRef idx="2">
+            <a:schemeClr val="accent1"/>
+          </a:effectRef>
+          <a:fontRef idx="minor">
+            <a:schemeClr val="lt1"/>
+          </a:fontRef>
+        </p:style>
+        <p:txBody>
+          <a:bodyPr rtlCol="0" anchor="ctr"/>
+          <a:lstStyle/>
+          <a:p>
+            <a:pPr algn="ctr"/>
+          </a:p>
+        </p:txBody>
+      </p:sp>
+      <p:sp>
+        <p:nvSpPr>
+          <p:cNvPr id="70" name="TextBox 69"/>
+          <p:cNvSpPr txBox="1"/>
+          <p:nvPr/>
+        </p:nvSpPr>
+        <p:spPr>
+          <a:xfrm>
+            <a:off x="10945368" y="5367528"/>
+            <a:ext cx="457200" cy="411480"/>
+          </a:xfrm>
+          <a:prstGeom prst="rect">
+            <a:avLst/>
+          </a:prstGeom>
+          <a:noFill/>
+        </p:spPr>
+        <p:txBody>
+          <a:bodyPr wrap="square">
+            <a:spAutoFit/>
+          </a:bodyPr>
+          <a:lstStyle/>
+          <a:p>
+            <a:pPr algn="ctr"/>
+            <a:r>
+              <a:rPr sz="2000" b="0" i="0">
+                <a:solidFill>
+                  <a:srgbClr val="FFFFFF"/>
+                </a:solidFill>
+              </a:rPr>
+              <a:t>📥</a:t>
+            </a:r>
+          </a:p>
+        </p:txBody>
+      </p:sp>
+      <p:sp>
+        <p:nvSpPr>
+          <p:cNvPr id="71" name="TextBox 70"/>
+          <p:cNvSpPr txBox="1"/>
+          <p:nvPr/>
+        </p:nvSpPr>
+        <p:spPr>
+          <a:xfrm>
+            <a:off x="10442448" y="5779008"/>
+            <a:ext cx="1463040" cy="274320"/>
+          </a:xfrm>
+          <a:prstGeom prst="rect">
+            <a:avLst/>
+          </a:prstGeom>
+          <a:noFill/>
+        </p:spPr>
+        <p:txBody>
+          <a:bodyPr wrap="square">
+            <a:spAutoFit/>
+          </a:bodyPr>
+          <a:lstStyle/>
+          <a:p>
+            <a:pPr algn="ctr"/>
+            <a:r>
+              <a:rPr sz="950" b="1" i="0">
+                <a:solidFill>
+                  <a:srgbClr val="F6AD55"/>
+                </a:solidFill>
+              </a:rPr>
+              <a:t>Multi-Format</a:t>
+            </a:r>
+          </a:p>
+        </p:txBody>
+      </p:sp>
+      <p:sp>
+        <p:nvSpPr>
+          <p:cNvPr id="72" name="TextBox 71"/>
+          <p:cNvSpPr txBox="1"/>
+          <p:nvPr/>
+        </p:nvSpPr>
+        <p:spPr>
+          <a:xfrm>
+            <a:off x="10442448" y="6053328"/>
+            <a:ext cx="1463040" cy="594360"/>
+          </a:xfrm>
+          <a:prstGeom prst="rect">
+            <a:avLst/>
+          </a:prstGeom>
+          <a:noFill/>
+        </p:spPr>
+        <p:txBody>
+          <a:bodyPr wrap="square">
+            <a:spAutoFit/>
+          </a:bodyPr>
+          <a:lstStyle/>
+          <a:p>
+            <a:pPr algn="ctr"/>
+            <a:r>
+              <a:rPr sz="850" b="0" i="0">
+                <a:solidFill>
+                  <a:srgbClr val="718096"/>
+                </a:solidFill>
+              </a:rPr>
+              <a:t>CSV for flat data · JSON for nested schemas</a:t>
+            </a:r>
+          </a:p>
+        </p:txBody>
+      </p:sp>
+      <p:sp>
+        <p:nvSpPr>
+          <p:cNvPr id="73" name="Rectangle 72"/>
+          <p:cNvSpPr/>
+          <p:nvPr/>
+        </p:nvSpPr>
+        <p:spPr>
+          <a:xfrm>
+            <a:off x="0" y="6784848"/>
+            <a:ext cx="12188952" cy="73152"/>
+          </a:xfrm>
+          <a:prstGeom prst="rect">
+            <a:avLst/>
+          </a:prstGeom>
+          <a:solidFill>
+            <a:srgbClr val="63B3ED"/>
+          </a:solidFill>
+          <a:ln>
+            <a:noFill/>
+          </a:ln>
+        </p:spPr>
+        <p:style>
+          <a:lnRef idx="1">
+            <a:schemeClr val="accent1"/>
+          </a:lnRef>
+          <a:fillRef idx="3">
+            <a:schemeClr val="accent1"/>
+          </a:fillRef>
+          <a:effectRef idx="2">
+            <a:schemeClr val="accent1"/>
+          </a:effectRef>
+          <a:fontRef idx="minor">
+            <a:schemeClr val="lt1"/>
+          </a:fontRef>
+        </p:style>
+        <p:txBody>
+          <a:bodyPr rtlCol="0" anchor="ctr"/>
+          <a:lstStyle/>
+          <a:p>
+            <a:pPr algn="ctr"/>
+          </a:p>
+        </p:txBody>
+      </p:sp>
+      <p:sp>
+        <p:nvSpPr>
+          <p:cNvPr id="74" name="TextBox 73"/>
+          <p:cNvSpPr txBox="1"/>
+          <p:nvPr/>
+        </p:nvSpPr>
+        <p:spPr>
+          <a:xfrm>
+            <a:off x="0" y="6675120"/>
+            <a:ext cx="12188952" cy="274320"/>
+          </a:xfrm>
+          <a:prstGeom prst="rect">
+            <a:avLst/>
+          </a:prstGeom>
+          <a:noFill/>
+        </p:spPr>
+        <p:txBody>
+          <a:bodyPr wrap="square">
+            <a:spAutoFit/>
+          </a:bodyPr>
+          <a:lstStyle/>
+          <a:p>
+            <a:pPr algn="ctr"/>
+            <a:r>
+              <a:rPr sz="850" b="0" i="0">
+                <a:solidFill>
+                  <a:srgbClr val="718096"/>
+                </a:solidFill>
+              </a:rPr>
+              <a:t>Powered by Databricks · Claude Sonnet · Streamlit  ·  Extend with new schemas in 3 steps — PROMPT_TEMPLATES · COLUMN_NAMES · UI selector</a:t>
             </a:r>
           </a:p>
         </p:txBody>

</xml_diff>